<commit_message>
feat(pptx, odp): a PDF's lines spaced as measured, its tables' text in place over a page picture
A page's paragraph keeps the distance from one baseline to the next (spcPts, fo:line-height). Where a picture is drawn behind the page's slide (backgrounds), a table's rules are in the picture: its cells' text is placed over it where it was, not drawn as a second table. Tables are laid out as DOCX and ODT lay them out (a sparse sheet's cells at their own columns, merges covering what they span).
</commit_message>
<xml_diff>
--- a/test/generator/baseline/gen.docx.to.pptx.pptx
+++ b/test/generator/baseline/gen.docx.to.pptx.pptx
@@ -1771,14 +1771,34 @@
             <a:tbl>
               <a:tblPr firstRow="1"/>
               <a:tblGrid>
-                <a:gridCol w="748145"/>
-                <a:gridCol w="7481455"/>
+                <a:gridCol w="2554014"/>
+                <a:gridCol w="5675586"/>
               </a:tblGrid>
               <a:tr h="3683000">
                 <a:tc>
                   <a:txBody>
                     <a:bodyPr/>
                     <a:lstStyle/>
+                    <a:p>
+                      <a:pPr>
+                        <a:buNone/>
+                      </a:pPr>
+                      <a:r>
+                        <a:rPr lang="en-US" sz="1200" dirty="0"/>
+                        <a:t>OneThree	Two</a:t>
+                      </a:r>
+                      <a:endParaRPr lang="en-US" sz="1200" dirty="0"/>
+                    </a:p>
+                    <a:p>
+                      <a:pPr>
+                        <a:buNone/>
+                      </a:pPr>
+                      <a:r>
+                        <a:rPr lang="en-US" sz="1200" dirty="0"/>
+                        <a:t>Four</a:t>
+                      </a:r>
+                      <a:endParaRPr lang="en-US" sz="1200" dirty="0"/>
+                    </a:p>
                     <a:p>
                       <a:pPr>
                         <a:buNone/>

</xml_diff>